<commit_message>
Improve CNC UDP streaming with human-face tracking stability and Mach4 work pose.
Add mismatch tracking, hold-last safety, Mach4 work-pose UDP bridge, and robust pose filtering for live faces. Remove legacy TCP streaming and document the UDP compensation pipeline.

Co-authored-by: Cursor <cursoragent@cursor.com>
</commit_message>
<xml_diff>
--- a/docs/pipeline.pptx
+++ b/docs/pipeline.pptx
@@ -5,10 +5,11 @@
     <p:sldMasterId id="2147483660" r:id="rId1"/>
   </p:sldMasterIdLst>
   <p:notesMasterIdLst>
-    <p:notesMasterId r:id="rId3"/>
+    <p:notesMasterId r:id="rId4"/>
   </p:notesMasterIdLst>
   <p:sldIdLst>
     <p:sldId id="1459" r:id="rId2"/>
+    <p:sldId id="1460" r:id="rId3"/>
   </p:sldIdLst>
   <p:sldSz cx="12192000" cy="6858000"/>
   <p:notesSz cx="6858000" cy="9144000"/>
@@ -113,6 +114,7 @@
         <p14:section name="默认节" id="{1701D7A1-5CCF-4D46-972C-2DB8C3E8ED58}">
           <p14:sldIdLst>
             <p14:sldId id="1459"/>
+            <p14:sldId id="1460"/>
           </p14:sldIdLst>
         </p14:section>
         <p14:section name="Supplemental" id="{0FADBF4E-EDCB-4F47-A4CE-1553AE821892}">
@@ -217,7 +219,7 @@
           <a:p>
             <a:fld id="{07023E9A-94C7-4801-999E-EBFC142D1F12}" type="datetimeFigureOut">
               <a:rPr lang="en-US" smtClean="0"/>
-              <a:t>5/29/2026</a:t>
+              <a:t>6/29/2026</a:t>
             </a:fld>
             <a:endParaRPr lang="en-US"/>
           </a:p>
@@ -643,6 +645,174 @@
     <p:extLst>
       <p:ext uri="{BB962C8B-B14F-4D97-AF65-F5344CB8AC3E}">
         <p14:creationId xmlns:p14="http://schemas.microsoft.com/office/powerpoint/2010/main" val="3277213686"/>
+      </p:ext>
+    </p:extLst>
+  </p:cSld>
+  <p:clrMapOvr>
+    <a:masterClrMapping/>
+  </p:clrMapOvr>
+</p:notes>
+</file>
+
+<file path=ppt/notesSlides/notesSlide2.xml><?xml version="1.0" encoding="utf-8"?>
+<p:notes xmlns:a="http://schemas.openxmlformats.org/drawingml/2006/main" xmlns:r="http://schemas.openxmlformats.org/officeDocument/2006/relationships" xmlns:p="http://schemas.openxmlformats.org/presentationml/2006/main">
+  <p:cSld>
+    <p:spTree>
+      <p:nvGrpSpPr>
+        <p:cNvPr id="1" name="">
+          <a:extLst>
+            <a:ext uri="{FF2B5EF4-FFF2-40B4-BE49-F238E27FC236}">
+              <a16:creationId xmlns:a16="http://schemas.microsoft.com/office/drawing/2014/main" id="{554C1107-D5F4-1350-44F3-E8CA9672564D}"/>
+            </a:ext>
+          </a:extLst>
+        </p:cNvPr>
+        <p:cNvGrpSpPr/>
+        <p:nvPr/>
+      </p:nvGrpSpPr>
+      <p:grpSpPr>
+        <a:xfrm>
+          <a:off x="0" y="0"/>
+          <a:ext cx="0" cy="0"/>
+          <a:chOff x="0" y="0"/>
+          <a:chExt cx="0" cy="0"/>
+        </a:xfrm>
+      </p:grpSpPr>
+      <p:sp>
+        <p:nvSpPr>
+          <p:cNvPr id="2" name="Slide Image Placeholder 1">
+            <a:extLst>
+              <a:ext uri="{FF2B5EF4-FFF2-40B4-BE49-F238E27FC236}">
+                <a16:creationId xmlns:a16="http://schemas.microsoft.com/office/drawing/2014/main" id="{97DB2B57-4905-CC63-6709-859E47AE60CA}"/>
+              </a:ext>
+            </a:extLst>
+          </p:cNvPr>
+          <p:cNvSpPr>
+            <a:spLocks noGrp="1" noRot="1" noChangeAspect="1"/>
+          </p:cNvSpPr>
+          <p:nvPr>
+            <p:ph type="sldImg"/>
+          </p:nvPr>
+        </p:nvSpPr>
+        <p:spPr/>
+      </p:sp>
+      <p:sp>
+        <p:nvSpPr>
+          <p:cNvPr id="3" name="Notes Placeholder 2">
+            <a:extLst>
+              <a:ext uri="{FF2B5EF4-FFF2-40B4-BE49-F238E27FC236}">
+                <a16:creationId xmlns:a16="http://schemas.microsoft.com/office/drawing/2014/main" id="{A1DB23AC-0440-6EE6-09F2-FE0EA6D06C6F}"/>
+              </a:ext>
+            </a:extLst>
+          </p:cNvPr>
+          <p:cNvSpPr>
+            <a:spLocks noGrp="1"/>
+          </p:cNvSpPr>
+          <p:nvPr>
+            <p:ph type="body" idx="1"/>
+          </p:nvPr>
+        </p:nvSpPr>
+        <p:spPr/>
+        <p:txBody>
+          <a:bodyPr/>
+          <a:lstStyle/>
+          <a:p>
+            <a:endParaRPr lang="en-US" dirty="0"/>
+          </a:p>
+        </p:txBody>
+      </p:sp>
+      <p:sp>
+        <p:nvSpPr>
+          <p:cNvPr id="4" name="Slide Number Placeholder 3">
+            <a:extLst>
+              <a:ext uri="{FF2B5EF4-FFF2-40B4-BE49-F238E27FC236}">
+                <a16:creationId xmlns:a16="http://schemas.microsoft.com/office/drawing/2014/main" id="{CA51EC1D-B219-3AE2-BF43-77B3FDAEFB86}"/>
+              </a:ext>
+            </a:extLst>
+          </p:cNvPr>
+          <p:cNvSpPr>
+            <a:spLocks noGrp="1"/>
+          </p:cNvSpPr>
+          <p:nvPr>
+            <p:ph type="sldNum" sz="quarter" idx="5"/>
+          </p:nvPr>
+        </p:nvSpPr>
+        <p:spPr/>
+        <p:txBody>
+          <a:bodyPr/>
+          <a:lstStyle/>
+          <a:p>
+            <a:pPr marL="0" marR="0" lvl="0" indent="0" algn="r" defTabSz="914400" rtl="0" eaLnBrk="1" fontAlgn="auto" latinLnBrk="0" hangingPunct="1">
+              <a:lnSpc>
+                <a:spcPct val="100000"/>
+              </a:lnSpc>
+              <a:spcBef>
+                <a:spcPts val="0"/>
+              </a:spcBef>
+              <a:spcAft>
+                <a:spcPts val="0"/>
+              </a:spcAft>
+              <a:buClrTx/>
+              <a:buSzTx/>
+              <a:buFontTx/>
+              <a:buNone/>
+              <a:tabLst/>
+              <a:defRPr/>
+            </a:pPr>
+            <a:fld id="{D4753937-6C74-4D31-AC93-2D83882E2694}" type="slidenum">
+              <a:rPr kumimoji="0" lang="en-US" sz="1200" b="0" i="0" u="none" strike="noStrike" kern="1200" cap="none" spc="0" normalizeH="0" baseline="0" noProof="0" smtClean="0">
+                <a:ln>
+                  <a:noFill/>
+                </a:ln>
+                <a:solidFill>
+                  <a:prstClr val="black"/>
+                </a:solidFill>
+                <a:effectLst/>
+                <a:uLnTx/>
+                <a:uFillTx/>
+                <a:latin typeface="Calibri" panose="020F0502020204030204"/>
+                <a:ea typeface="+mn-ea"/>
+                <a:cs typeface="+mn-cs"/>
+              </a:rPr>
+              <a:pPr marL="0" marR="0" lvl="0" indent="0" algn="r" defTabSz="914400" rtl="0" eaLnBrk="1" fontAlgn="auto" latinLnBrk="0" hangingPunct="1">
+                <a:lnSpc>
+                  <a:spcPct val="100000"/>
+                </a:lnSpc>
+                <a:spcBef>
+                  <a:spcPts val="0"/>
+                </a:spcBef>
+                <a:spcAft>
+                  <a:spcPts val="0"/>
+                </a:spcAft>
+                <a:buClrTx/>
+                <a:buSzTx/>
+                <a:buFontTx/>
+                <a:buNone/>
+                <a:tabLst/>
+                <a:defRPr/>
+              </a:pPr>
+              <a:t>2</a:t>
+            </a:fld>
+            <a:endParaRPr kumimoji="0" lang="en-US" sz="1200" b="0" i="0" u="none" strike="noStrike" kern="1200" cap="none" spc="0" normalizeH="0" baseline="0" noProof="0">
+              <a:ln>
+                <a:noFill/>
+              </a:ln>
+              <a:solidFill>
+                <a:prstClr val="black"/>
+              </a:solidFill>
+              <a:effectLst/>
+              <a:uLnTx/>
+              <a:uFillTx/>
+              <a:latin typeface="Calibri" panose="020F0502020204030204"/>
+              <a:ea typeface="+mn-ea"/>
+              <a:cs typeface="+mn-cs"/>
+            </a:endParaRPr>
+          </a:p>
+        </p:txBody>
+      </p:sp>
+    </p:spTree>
+    <p:extLst>
+      <p:ext uri="{BB962C8B-B14F-4D97-AF65-F5344CB8AC3E}">
+        <p14:creationId xmlns:p14="http://schemas.microsoft.com/office/powerpoint/2010/main" val="4191871473"/>
       </p:ext>
     </p:extLst>
   </p:cSld>
@@ -2083,6 +2253,109 @@
     <p:extLst>
       <p:ext uri="{BB962C8B-B14F-4D97-AF65-F5344CB8AC3E}">
         <p14:creationId xmlns:p14="http://schemas.microsoft.com/office/powerpoint/2010/main" val="2776588320"/>
+      </p:ext>
+    </p:extLst>
+  </p:cSld>
+  <p:clrMapOvr>
+    <a:masterClrMapping/>
+  </p:clrMapOvr>
+</p:sld>
+</file>
+
+<file path=ppt/slides/slide2.xml><?xml version="1.0" encoding="utf-8"?>
+<p:sld xmlns:a="http://schemas.openxmlformats.org/drawingml/2006/main" xmlns:r="http://schemas.openxmlformats.org/officeDocument/2006/relationships" xmlns:p="http://schemas.openxmlformats.org/presentationml/2006/main">
+  <p:cSld>
+    <p:spTree>
+      <p:nvGrpSpPr>
+        <p:cNvPr id="1" name="">
+          <a:extLst>
+            <a:ext uri="{FF2B5EF4-FFF2-40B4-BE49-F238E27FC236}">
+              <a16:creationId xmlns:a16="http://schemas.microsoft.com/office/drawing/2014/main" id="{87F2DBC2-64F3-C281-F8F8-BA71D31E4FE8}"/>
+            </a:ext>
+          </a:extLst>
+        </p:cNvPr>
+        <p:cNvGrpSpPr/>
+        <p:nvPr/>
+      </p:nvGrpSpPr>
+      <p:grpSpPr>
+        <a:xfrm>
+          <a:off x="0" y="0"/>
+          <a:ext cx="0" cy="0"/>
+          <a:chOff x="0" y="0"/>
+          <a:chExt cx="0" cy="0"/>
+        </a:xfrm>
+      </p:grpSpPr>
+      <p:sp>
+        <p:nvSpPr>
+          <p:cNvPr id="3" name="Title 2">
+            <a:extLst>
+              <a:ext uri="{FF2B5EF4-FFF2-40B4-BE49-F238E27FC236}">
+                <a16:creationId xmlns:a16="http://schemas.microsoft.com/office/drawing/2014/main" id="{11F9DDDB-37D0-F09A-2503-4FFC917B6B2B}"/>
+              </a:ext>
+            </a:extLst>
+          </p:cNvPr>
+          <p:cNvSpPr>
+            <a:spLocks noGrp="1"/>
+          </p:cNvSpPr>
+          <p:nvPr>
+            <p:ph type="title"/>
+          </p:nvPr>
+        </p:nvSpPr>
+        <p:spPr/>
+        <p:txBody>
+          <a:bodyPr>
+            <a:normAutofit/>
+          </a:bodyPr>
+          <a:lstStyle/>
+          <a:p>
+            <a:r>
+              <a:rPr lang="en-US" altLang="zh-CN" dirty="0"/>
+              <a:t>Closed-loop control</a:t>
+            </a:r>
+            <a:endParaRPr lang="en-US" dirty="0"/>
+          </a:p>
+        </p:txBody>
+      </p:sp>
+      <p:pic>
+        <p:nvPicPr>
+          <p:cNvPr id="14" name="图形 13">
+            <a:extLst>
+              <a:ext uri="{FF2B5EF4-FFF2-40B4-BE49-F238E27FC236}">
+                <a16:creationId xmlns:a16="http://schemas.microsoft.com/office/drawing/2014/main" id="{CCF759B0-691C-BFF4-AE4B-36619D375D74}"/>
+              </a:ext>
+            </a:extLst>
+          </p:cNvPr>
+          <p:cNvPicPr>
+            <a:picLocks noChangeAspect="1"/>
+          </p:cNvPicPr>
+          <p:nvPr/>
+        </p:nvPicPr>
+        <p:blipFill>
+          <a:blip>
+            <a:extLst>
+              <a:ext uri="{96DAC541-7B7A-43D3-8B79-37D633B846F1}">
+                <asvg:svgBlip xmlns:asvg="http://schemas.microsoft.com/office/drawing/2016/SVG/main" r:embed="rId3"/>
+              </a:ext>
+            </a:extLst>
+          </a:blip>
+          <a:stretch>
+            <a:fillRect/>
+          </a:stretch>
+        </p:blipFill>
+        <p:spPr>
+          <a:xfrm>
+            <a:off x="0" y="2558143"/>
+            <a:ext cx="12192000" cy="1741714"/>
+          </a:xfrm>
+          <a:prstGeom prst="rect">
+            <a:avLst/>
+          </a:prstGeom>
+        </p:spPr>
+      </p:pic>
+    </p:spTree>
+    <p:extLst>
+      <p:ext uri="{BB962C8B-B14F-4D97-AF65-F5344CB8AC3E}">
+        <p14:creationId xmlns:p14="http://schemas.microsoft.com/office/powerpoint/2010/main" val="2166087067"/>
       </p:ext>
     </p:extLst>
   </p:cSld>

</xml_diff>